<commit_message>
Add BCH bank credit to agriculture 2017-2026 to the Honduras year-by-year table
Loans outstanding and new loans to all agriculture (BCH, coffee not
separated) with year-on-year changes; Jan-Jul 2026 new loans +84 % on
Jan-Jul 2025. 2025 Bono volume marked as read.

Co-Authored-By: Claude Opus 5.5 <noreply@anthropic.com>
Claude-Session: https://claude.ai/code/session_01GCSUFXh2mYdWNgg7VCeE1G
</commit_message>
<xml_diff>
--- a/research/honduras/slides/Honduras_YoY_productivity_inputs_finance_fx.pptx
+++ b/research/honduras/slides/Honduras_YoY_productivity_inputs_finance_fx.pptx
@@ -14560,7 +14560,7 @@
                 <a:latin typeface="Arial"/>
                 <a:cs typeface="Arial"/>
               </a:rPr>
-              <a:t>300,000 qq of fertiliser</a:t>
+              <a:t>300 000 qq of fertiliser (read, El Heraldo 2026); L350 M not verified</a:t>
             </a:r>
           </a:p>
         </p:txBody>
@@ -14945,14 +14945,14 @@
               <a:buNone/>
             </a:pPr>
             <a:r>
-              <a:rPr lang="en-GB" sz="850" dirty="0">
-                <a:solidFill>
-                  <a:srgbClr val="262626"/>
-                </a:solidFill>
-                <a:latin typeface="Arial"/>
-                <a:cs typeface="Arial"/>
-              </a:rPr>
-              <a:t>Pattern: money arrives after the damage (2002 price crisis, 2013 rust, 2018 low prices, 2020–21 Covid and hurricanes, 2025 Bono) and mostly as fertiliser or refinancing. In 2013 only L335 M of L1 715 M offered was taken by April 2014: credit on offer is not credit used. A yearly BCH series of bank loans to coffee was not reachable.</a:t>
+              <a:rPr lang="en-GB" sz="830" dirty="0">
+                <a:solidFill>
+                  <a:srgbClr val="262626"/>
+                </a:solidFill>
+                <a:latin typeface="Arial"/>
+                <a:cs typeface="Arial"/>
+              </a:rPr>
+              <a:t>Pattern: money arrives after the damage (2002 price crisis, 2013 rust, 2018 low prices, 2020–21 Covid and hurricanes, 2025 Bono) and mostly as fertiliser or refinancing; in 2013 only L335 M of L1 715 M offered was taken. Bank credit to all agriculture (BCH; coffee not separated): new loans L16 237 M in 2018, L14 129 M in 2020 (−8 %), L19 080 M in 2025 (+12 %); Jan–Jul 2026 L19 250 M, +84 % on Jan–Jul 2025.</a:t>
             </a:r>
           </a:p>
         </p:txBody>
@@ -14999,7 +14999,7 @@
                 <a:latin typeface="Arial"/>
                 <a:cs typeface="Arial"/>
               </a:rPr>
-              <a:t>USDA FAS Coffee Annual Honduras 2011–2021; El Heraldo 7 Apr 2014 and 29 Aug 2018 (read); Decreto 93-2018; La Tribuna 25 Jun 2021 (debt, search summary). Lempiras converted at the BCH yearly mean rate.</a:t>
+              <a:t>USDA FAS Coffee Annual Honduras 2011–2021; El Heraldo 7 Apr 2014 and 29 Aug 2018 (read); Decreto 93-2018; La Tribuna 25 Jun 2021 (debt, search summary); BCH loans by activity (xlsx, read). Lempiras converted at the BCH yearly mean rate.</a:t>
             </a:r>
           </a:p>
         </p:txBody>

</xml_diff>

<commit_message>
Add the August 2017 IHCAFE early-warning bulletin to the Honduras rust list
Co-Authored-By: Claude Opus 5.5 <noreply@anthropic.com>
Claude-Session: https://claude.ai/code/session_01GCSUFXh2mYdWNgg7VCeE1G
</commit_message>
<xml_diff>
--- a/research/honduras/slides/Honduras_YoY_productivity_inputs_finance_fx.pptx
+++ b/research/honduras/slides/Honduras_YoY_productivity_inputs_finance_fx.pptx
@@ -8002,7 +8002,7 @@
                 <a:latin typeface="Arial"/>
                 <a:cs typeface="Arial"/>
               </a:rPr>
-              <a:t>2020</a:t>
+              <a:t>2017</a:t>
             </a:r>
           </a:p>
         </p:txBody>
@@ -8051,7 +8051,7 @@
                 <a:latin typeface="Arial"/>
                 <a:cs typeface="Arial"/>
               </a:rPr>
-              <a:t>end 2020</a:t>
+              <a:t>Aug 2017</a:t>
             </a:r>
           </a:p>
         </p:txBody>
@@ -8100,7 +8100,7 @@
                 <a:latin typeface="Arial"/>
                 <a:cs typeface="Arial"/>
               </a:rPr>
-              <a:t>15–25</a:t>
+              <a:t/>
             </a:r>
           </a:p>
         </p:txBody>
@@ -8149,7 +8149,7 @@
                 <a:latin typeface="Arial"/>
                 <a:cs typeface="Arial"/>
               </a:rPr>
-              <a:t>incidence in 5 departments after hurricanes Eta and Iota</a:t>
+              <a:t>IHCAFE SAT bulletin No 6: rust on susceptible varieties green alert (low risk); on resistant varieties and berry borer blue alert (minimal risk)</a:t>
             </a:r>
           </a:p>
         </p:txBody>
@@ -8198,7 +8198,7 @@
                 <a:latin typeface="Arial"/>
                 <a:cs typeface="Arial"/>
               </a:rPr>
-              <a:t>GAIN 2021</a:t>
+              <a:t>IHCAFE SAT page (image, read)</a:t>
             </a:r>
           </a:p>
         </p:txBody>
@@ -8296,7 +8296,7 @@
                 <a:latin typeface="Arial"/>
                 <a:cs typeface="Arial"/>
               </a:rPr>
-              <a:t>Nov 2020</a:t>
+              <a:t>end 2020</a:t>
             </a:r>
           </a:p>
         </p:txBody>
@@ -8345,7 +8345,7 @@
                 <a:latin typeface="Arial"/>
                 <a:cs typeface="Arial"/>
               </a:rPr>
-              <a:t/>
+              <a:t>15–25</a:t>
             </a:r>
           </a:p>
         </p:txBody>
@@ -8394,7 +8394,7 @@
                 <a:latin typeface="Arial"/>
                 <a:cs typeface="Arial"/>
               </a:rPr>
-              <a:t>Eta and Iota: &gt; 4 200 ha of coffee farms hit, &gt; 150 000 qq lost</a:t>
+              <a:t>incidence in 5 departments after hurricanes Eta and Iota</a:t>
             </a:r>
           </a:p>
         </p:txBody>
@@ -8443,7 +8443,7 @@
                 <a:latin typeface="Arial"/>
                 <a:cs typeface="Arial"/>
               </a:rPr>
-              <a:t>La Prensa / EFE 1 Nov 2022 (read)</a:t>
+              <a:t>GAIN 2021</a:t>
             </a:r>
           </a:p>
         </p:txBody>
@@ -8492,7 +8492,7 @@
                 <a:latin typeface="Arial"/>
                 <a:cs typeface="Arial"/>
               </a:rPr>
-              <a:t>2022</a:t>
+              <a:t>2020</a:t>
             </a:r>
           </a:p>
         </p:txBody>
@@ -8541,7 +8541,7 @@
                 <a:latin typeface="Arial"/>
                 <a:cs typeface="Arial"/>
               </a:rPr>
-              <a:t>2022/23 crop</a:t>
+              <a:t>Nov 2020</a:t>
             </a:r>
           </a:p>
         </p:txBody>
@@ -8590,7 +8590,7 @@
                 <a:latin typeface="Arial"/>
                 <a:cs typeface="Arial"/>
               </a:rPr>
-              <a:t>20</a:t>
+              <a:t/>
             </a:r>
           </a:p>
         </p:txBody>
@@ -8639,7 +8639,7 @@
                 <a:latin typeface="Arial"/>
                 <a:cs typeface="Arial"/>
               </a:rPr>
-              <a:t>% of PRODUCTION affected by rust (IHCAFE director)</a:t>
+              <a:t>Eta and Iota: &gt; 4 200 ha of coffee farms hit, &gt; 150 000 qq lost</a:t>
             </a:r>
           </a:p>
         </p:txBody>
@@ -8786,7 +8786,7 @@
                 <a:latin typeface="Arial"/>
                 <a:cs typeface="Arial"/>
               </a:rPr>
-              <a:t>Apr 2022</a:t>
+              <a:t>2022/23 crop</a:t>
             </a:r>
           </a:p>
         </p:txBody>
@@ -8835,7 +8835,7 @@
                 <a:latin typeface="Arial"/>
                 <a:cs typeface="Arial"/>
               </a:rPr>
-              <a:t>5,42</a:t>
+              <a:t>20</a:t>
             </a:r>
           </a:p>
         </p:txBody>
@@ -8884,7 +8884,7 @@
                 <a:latin typeface="Arial"/>
                 <a:cs typeface="Arial"/>
               </a:rPr>
-              <a:t>national average incidence (66 % of farms low, 29 % medium, 5 % high)</a:t>
+              <a:t>% of PRODUCTION affected by rust (IHCAFE director)</a:t>
             </a:r>
           </a:p>
         </p:txBody>
@@ -8933,7 +8933,7 @@
                 <a:latin typeface="Arial"/>
                 <a:cs typeface="Arial"/>
               </a:rPr>
-              <a:t>GAIN 2022</a:t>
+              <a:t>La Prensa / EFE 1 Nov 2022 (read)</a:t>
             </a:r>
           </a:p>
         </p:txBody>
@@ -8982,7 +8982,7 @@
                 <a:latin typeface="Arial"/>
                 <a:cs typeface="Arial"/>
               </a:rPr>
-              <a:t>2023</a:t>
+              <a:t>2022</a:t>
             </a:r>
           </a:p>
         </p:txBody>
@@ -9031,7 +9031,7 @@
                 <a:latin typeface="Arial"/>
                 <a:cs typeface="Arial"/>
               </a:rPr>
-              <a:t>May 2023</a:t>
+              <a:t>Apr 2022</a:t>
             </a:r>
           </a:p>
         </p:txBody>
@@ -9080,7 +9080,7 @@
                 <a:latin typeface="Arial"/>
                 <a:cs typeface="Arial"/>
               </a:rPr>
-              <a:t>5,80</a:t>
+              <a:t>5,42</a:t>
             </a:r>
           </a:p>
         </p:txBody>
@@ -9129,7 +9129,7 @@
                 <a:latin typeface="Arial"/>
                 <a:cs typeface="Arial"/>
               </a:rPr>
-              <a:t>national average incidence (La Paz 9.7 %, Fco. Morazan 8.2 %)</a:t>
+              <a:t>national average incidence (66 % of farms low, 29 % medium, 5 % high)</a:t>
             </a:r>
           </a:p>
         </p:txBody>
@@ -9178,7 +9178,7 @@
                 <a:latin typeface="Arial"/>
                 <a:cs typeface="Arial"/>
               </a:rPr>
-              <a:t>GAIN 2023 (repeated in GAIN 2024)</a:t>
+              <a:t>GAIN 2022</a:t>
             </a:r>
           </a:p>
         </p:txBody>
@@ -9227,7 +9227,7 @@
                 <a:latin typeface="Arial"/>
                 <a:cs typeface="Arial"/>
               </a:rPr>
-              <a:t>2024</a:t>
+              <a:t>2023</a:t>
             </a:r>
           </a:p>
         </p:txBody>
@@ -9276,7 +9276,7 @@
                 <a:latin typeface="Arial"/>
                 <a:cs typeface="Arial"/>
               </a:rPr>
-              <a:t>Mar 2024</a:t>
+              <a:t>May 2023</a:t>
             </a:r>
           </a:p>
         </p:txBody>
@@ -9320,12 +9320,12 @@
             <a:r>
               <a:rPr lang="en-GB" sz="730" b="1" dirty="0">
                 <a:solidFill>
-                  <a:srgbClr val="C00000"/>
-                </a:solidFill>
-                <a:latin typeface="Arial"/>
-                <a:cs typeface="Arial"/>
-              </a:rPr>
-              <a:t>7,38 ⚠</a:t>
+                  <a:srgbClr val="262626"/>
+                </a:solidFill>
+                <a:latin typeface="Arial"/>
+                <a:cs typeface="Arial"/>
+              </a:rPr>
+              <a:t>5,80</a:t>
             </a:r>
           </a:p>
         </p:txBody>
@@ -9374,7 +9374,7 @@
                 <a:latin typeface="Arial"/>
                 <a:cs typeface="Arial"/>
               </a:rPr>
-              <a:t>national average incidence</a:t>
+              <a:t>national average incidence (La Paz 9.7 %, Fco. Morazan 8.2 %)</a:t>
             </a:r>
           </a:p>
         </p:txBody>
@@ -9423,7 +9423,7 @@
                 <a:latin typeface="Arial"/>
                 <a:cs typeface="Arial"/>
               </a:rPr>
-              <a:t>search summary (La Prensa / El Heraldo)</a:t>
+              <a:t>GAIN 2023 (repeated in GAIN 2024)</a:t>
             </a:r>
           </a:p>
         </p:txBody>
@@ -9521,7 +9521,7 @@
                 <a:latin typeface="Arial"/>
                 <a:cs typeface="Arial"/>
               </a:rPr>
-              <a:t>Apr 2024</a:t>
+              <a:t>Mar 2024</a:t>
             </a:r>
           </a:p>
         </p:txBody>
@@ -9565,12 +9565,12 @@
             <a:r>
               <a:rPr lang="en-GB" sz="730" b="1" dirty="0">
                 <a:solidFill>
-                  <a:srgbClr val="262626"/>
-                </a:solidFill>
-                <a:latin typeface="Arial"/>
-                <a:cs typeface="Arial"/>
-              </a:rPr>
-              <a:t/>
+                  <a:srgbClr val="C00000"/>
+                </a:solidFill>
+                <a:latin typeface="Arial"/>
+                <a:cs typeface="Arial"/>
+              </a:rPr>
+              <a:t>7,38 ⚠</a:t>
             </a:r>
           </a:p>
         </p:txBody>
@@ -9619,7 +9619,7 @@
                 <a:latin typeface="Arial"/>
                 <a:cs typeface="Arial"/>
               </a:rPr>
-              <a:t>76 % of sampled farms low, 19 % medium, 5 % high</a:t>
+              <a:t>national average incidence</a:t>
             </a:r>
           </a:p>
         </p:txBody>
@@ -9668,7 +9668,7 @@
                 <a:latin typeface="Arial"/>
                 <a:cs typeface="Arial"/>
               </a:rPr>
-              <a:t>GAIN 2025</a:t>
+              <a:t>search summary (La Prensa / El Heraldo)</a:t>
             </a:r>
           </a:p>
         </p:txBody>
@@ -9766,7 +9766,7 @@
                 <a:latin typeface="Arial"/>
                 <a:cs typeface="Arial"/>
               </a:rPr>
-              <a:t>2024</a:t>
+              <a:t>Apr 2024</a:t>
             </a:r>
           </a:p>
         </p:txBody>
@@ -9864,7 +9864,7 @@
                 <a:latin typeface="Arial"/>
                 <a:cs typeface="Arial"/>
               </a:rPr>
-              <a:t>BCH: exports about 500 000 qq lower than 2023 "due to high rust incidence and labour shortage"</a:t>
+              <a:t>76 % of sampled farms low, 19 % medium, 5 % high</a:t>
             </a:r>
           </a:p>
         </p:txBody>
@@ -9913,7 +9913,7 @@
                 <a:latin typeface="Arial"/>
                 <a:cs typeface="Arial"/>
               </a:rPr>
-              <a:t>El Heraldo 23 Jun 2024 (read)</a:t>
+              <a:t>GAIN 2025</a:t>
             </a:r>
           </a:p>
         </p:txBody>
@@ -9962,7 +9962,7 @@
                 <a:latin typeface="Arial"/>
                 <a:cs typeface="Arial"/>
               </a:rPr>
-              <a:t>2025</a:t>
+              <a:t>2024</a:t>
             </a:r>
           </a:p>
         </p:txBody>
@@ -10011,7 +10011,7 @@
                 <a:latin typeface="Arial"/>
                 <a:cs typeface="Arial"/>
               </a:rPr>
-              <a:t>Jan-Mar 2025</a:t>
+              <a:t>2024</a:t>
             </a:r>
           </a:p>
         </p:txBody>
@@ -10060,7 +10060,7 @@
                 <a:latin typeface="Arial"/>
                 <a:cs typeface="Arial"/>
               </a:rPr>
-              <a:t>5,71</a:t>
+              <a:t/>
             </a:r>
           </a:p>
         </p:txBody>
@@ -10109,7 +10109,7 @@
                 <a:latin typeface="Arial"/>
                 <a:cs typeface="Arial"/>
               </a:rPr>
-              <a:t>national average (13 of 15 departments hit; Santa Barbara 9.29 %, El Paraiso 7.91 %, Comayagua 7.20 %; worst varieties Obata and Catuai)</a:t>
+              <a:t>BCH: exports about 500 000 qq lower than 2023 "due to high rust incidence and labour shortage"</a:t>
             </a:r>
           </a:p>
         </p:txBody>
@@ -10158,7 +10158,7 @@
                 <a:latin typeface="Arial"/>
                 <a:cs typeface="Arial"/>
               </a:rPr>
-              <a:t>El Heraldo 13 May 2025 (read)</a:t>
+              <a:t>El Heraldo 23 Jun 2024 (read)</a:t>
             </a:r>
           </a:p>
         </p:txBody>
@@ -10256,7 +10256,7 @@
                 <a:latin typeface="Arial"/>
                 <a:cs typeface="Arial"/>
               </a:rPr>
-              <a:t>Apr 2025</a:t>
+              <a:t>Jan-Mar 2025</a:t>
             </a:r>
           </a:p>
         </p:txBody>
@@ -10305,7 +10305,7 @@
                 <a:latin typeface="Arial"/>
                 <a:cs typeface="Arial"/>
               </a:rPr>
-              <a:t/>
+              <a:t>5,71</a:t>
             </a:r>
           </a:p>
         </p:txBody>
@@ -10354,7 +10354,7 @@
                 <a:latin typeface="Arial"/>
                 <a:cs typeface="Arial"/>
               </a:rPr>
-              <a:t>sampled farms: 16.7 % medium (5-10 %), 7.8 % high (10-15 %), 21.6 % very high (&gt; 15 %)</a:t>
+              <a:t>national average (13 of 15 departments hit; Santa Barbara 9.29 %, El Paraiso 7.91 %, Comayagua 7.20 %; worst varieties Obata and Catuai)</a:t>
             </a:r>
           </a:p>
         </p:txBody>
@@ -10403,7 +10403,7 @@
                 <a:latin typeface="Arial"/>
                 <a:cs typeface="Arial"/>
               </a:rPr>
-              <a:t>GAIN 2026</a:t>
+              <a:t>El Heraldo 13 May 2025 (read)</a:t>
             </a:r>
           </a:p>
         </p:txBody>
@@ -10452,7 +10452,7 @@
                 <a:latin typeface="Arial"/>
                 <a:cs typeface="Arial"/>
               </a:rPr>
-              <a:t>2026</a:t>
+              <a:t>2025</a:t>
             </a:r>
           </a:p>
         </p:txBody>
@@ -10501,7 +10501,7 @@
                 <a:latin typeface="Arial"/>
                 <a:cs typeface="Arial"/>
               </a:rPr>
-              <a:t>end Jan 2026</a:t>
+              <a:t>Apr 2025</a:t>
             </a:r>
           </a:p>
         </p:txBody>
@@ -10550,7 +10550,7 @@
                 <a:latin typeface="Arial"/>
                 <a:cs typeface="Arial"/>
               </a:rPr>
-              <a:t>8,44</a:t>
+              <a:t/>
             </a:r>
           </a:p>
         </p:txBody>
@@ -10599,7 +10599,7 @@
                 <a:latin typeface="Arial"/>
                 <a:cs typeface="Arial"/>
               </a:rPr>
-              <a:t>national average incidence (from 7.57 %); departments 2.06-14.08 %; ~30 % of farms &gt; 10 %</a:t>
+              <a:t>sampled farms: 16.7 % medium (5-10 %), 7.8 % high (10-15 %), 21.6 % very high (&gt; 15 %)</a:t>
             </a:r>
           </a:p>
         </p:txBody>
@@ -10648,6 +10648,251 @@
                 <a:latin typeface="Arial"/>
                 <a:cs typeface="Arial"/>
               </a:rPr>
+              <a:t>GAIN 2026</a:t>
+            </a:r>
+          </a:p>
+        </p:txBody>
+      </p:sp>
+      <p:sp>
+        <p:nvSpPr>
+          <p:cNvPr id="79" name="TextBox 79"/>
+          <p:cNvSpPr txBox="1"/>
+          <p:nvPr/>
+        </p:nvSpPr>
+        <p:spPr>
+          <a:xfrm>
+            <a:off x="411480" y="5522976"/>
+            <a:ext cx="502920" cy="297180"/>
+          </a:xfrm>
+          <a:prstGeom prst="rect">
+            <a:avLst/>
+          </a:prstGeom>
+          <a:solidFill>
+            <a:srgbClr val="FFFFFF"/>
+          </a:solidFill>
+          <a:ln>
+            <a:noFill/>
+          </a:ln>
+        </p:spPr>
+        <p:txBody>
+          <a:bodyPr wrap="square" lIns="36576" tIns="27432" rIns="36576" bIns="27432" anchor="ctr" rtlCol="0">
+            <a:noAutofit/>
+          </a:bodyPr>
+          <a:lstStyle/>
+          <a:p>
+            <a:pPr algn="l" marL="0" indent="0">
+              <a:spcBef>
+                <a:spcPts val="0"/>
+              </a:spcBef>
+              <a:spcAft>
+                <a:spcPts val="0"/>
+              </a:spcAft>
+              <a:buNone/>
+            </a:pPr>
+            <a:r>
+              <a:rPr lang="en-GB" sz="730" dirty="0">
+                <a:solidFill>
+                  <a:srgbClr val="262626"/>
+                </a:solidFill>
+                <a:latin typeface="Arial"/>
+                <a:cs typeface="Arial"/>
+              </a:rPr>
+              <a:t>2026</a:t>
+            </a:r>
+          </a:p>
+        </p:txBody>
+      </p:sp>
+      <p:sp>
+        <p:nvSpPr>
+          <p:cNvPr id="80" name="TextBox 80"/>
+          <p:cNvSpPr txBox="1"/>
+          <p:nvPr/>
+        </p:nvSpPr>
+        <p:spPr>
+          <a:xfrm>
+            <a:off x="914400" y="5522976"/>
+            <a:ext cx="914400" cy="297180"/>
+          </a:xfrm>
+          <a:prstGeom prst="rect">
+            <a:avLst/>
+          </a:prstGeom>
+          <a:solidFill>
+            <a:srgbClr val="FFFFFF"/>
+          </a:solidFill>
+          <a:ln>
+            <a:noFill/>
+          </a:ln>
+        </p:spPr>
+        <p:txBody>
+          <a:bodyPr wrap="square" lIns="36576" tIns="27432" rIns="36576" bIns="27432" anchor="ctr" rtlCol="0">
+            <a:noAutofit/>
+          </a:bodyPr>
+          <a:lstStyle/>
+          <a:p>
+            <a:pPr algn="ctr" marL="0" indent="0">
+              <a:spcBef>
+                <a:spcPts val="0"/>
+              </a:spcBef>
+              <a:spcAft>
+                <a:spcPts val="0"/>
+              </a:spcAft>
+              <a:buNone/>
+            </a:pPr>
+            <a:r>
+              <a:rPr lang="en-GB" sz="730" dirty="0">
+                <a:solidFill>
+                  <a:srgbClr val="262626"/>
+                </a:solidFill>
+                <a:latin typeface="Arial"/>
+                <a:cs typeface="Arial"/>
+              </a:rPr>
+              <a:t>end Jan 2026</a:t>
+            </a:r>
+          </a:p>
+        </p:txBody>
+      </p:sp>
+      <p:sp>
+        <p:nvSpPr>
+          <p:cNvPr id="81" name="TextBox 81"/>
+          <p:cNvSpPr txBox="1"/>
+          <p:nvPr/>
+        </p:nvSpPr>
+        <p:spPr>
+          <a:xfrm>
+            <a:off x="1828800" y="5522976"/>
+            <a:ext cx="685800" cy="297180"/>
+          </a:xfrm>
+          <a:prstGeom prst="rect">
+            <a:avLst/>
+          </a:prstGeom>
+          <a:solidFill>
+            <a:srgbClr val="FFFFFF"/>
+          </a:solidFill>
+          <a:ln>
+            <a:noFill/>
+          </a:ln>
+        </p:spPr>
+        <p:txBody>
+          <a:bodyPr wrap="square" lIns="36576" tIns="27432" rIns="36576" bIns="27432" anchor="ctr" rtlCol="0">
+            <a:noAutofit/>
+          </a:bodyPr>
+          <a:lstStyle/>
+          <a:p>
+            <a:pPr algn="ctr" marL="0" indent="0">
+              <a:spcBef>
+                <a:spcPts val="0"/>
+              </a:spcBef>
+              <a:spcAft>
+                <a:spcPts val="0"/>
+              </a:spcAft>
+              <a:buNone/>
+            </a:pPr>
+            <a:r>
+              <a:rPr lang="en-GB" sz="730" b="1" dirty="0">
+                <a:solidFill>
+                  <a:srgbClr val="262626"/>
+                </a:solidFill>
+                <a:latin typeface="Arial"/>
+                <a:cs typeface="Arial"/>
+              </a:rPr>
+              <a:t>8,44</a:t>
+            </a:r>
+          </a:p>
+        </p:txBody>
+      </p:sp>
+      <p:sp>
+        <p:nvSpPr>
+          <p:cNvPr id="82" name="TextBox 82"/>
+          <p:cNvSpPr txBox="1"/>
+          <p:nvPr/>
+        </p:nvSpPr>
+        <p:spPr>
+          <a:xfrm>
+            <a:off x="2514600" y="5522976"/>
+            <a:ext cx="5303520" cy="297180"/>
+          </a:xfrm>
+          <a:prstGeom prst="rect">
+            <a:avLst/>
+          </a:prstGeom>
+          <a:solidFill>
+            <a:srgbClr val="FFFFFF"/>
+          </a:solidFill>
+          <a:ln>
+            <a:noFill/>
+          </a:ln>
+        </p:spPr>
+        <p:txBody>
+          <a:bodyPr wrap="square" lIns="36576" tIns="27432" rIns="36576" bIns="27432" anchor="ctr" rtlCol="0">
+            <a:noAutofit/>
+          </a:bodyPr>
+          <a:lstStyle/>
+          <a:p>
+            <a:pPr algn="ctr" marL="0" indent="0">
+              <a:spcBef>
+                <a:spcPts val="0"/>
+              </a:spcBef>
+              <a:spcAft>
+                <a:spcPts val="0"/>
+              </a:spcAft>
+              <a:buNone/>
+            </a:pPr>
+            <a:r>
+              <a:rPr lang="en-GB" sz="730" dirty="0">
+                <a:solidFill>
+                  <a:srgbClr val="262626"/>
+                </a:solidFill>
+                <a:latin typeface="Arial"/>
+                <a:cs typeface="Arial"/>
+              </a:rPr>
+              <a:t>national average incidence (from 7.57 %); departments 2.06-14.08 %; ~30 % of farms &gt; 10 %</a:t>
+            </a:r>
+          </a:p>
+        </p:txBody>
+      </p:sp>
+      <p:sp>
+        <p:nvSpPr>
+          <p:cNvPr id="83" name="TextBox 83"/>
+          <p:cNvSpPr txBox="1"/>
+          <p:nvPr/>
+        </p:nvSpPr>
+        <p:spPr>
+          <a:xfrm>
+            <a:off x="7818120" y="5522976"/>
+            <a:ext cx="1554480" cy="297180"/>
+          </a:xfrm>
+          <a:prstGeom prst="rect">
+            <a:avLst/>
+          </a:prstGeom>
+          <a:solidFill>
+            <a:srgbClr val="FFFFFF"/>
+          </a:solidFill>
+          <a:ln>
+            <a:noFill/>
+          </a:ln>
+        </p:spPr>
+        <p:txBody>
+          <a:bodyPr wrap="square" lIns="36576" tIns="27432" rIns="36576" bIns="27432" anchor="ctr" rtlCol="0">
+            <a:noAutofit/>
+          </a:bodyPr>
+          <a:lstStyle/>
+          <a:p>
+            <a:pPr algn="ctr" marL="0" indent="0">
+              <a:spcBef>
+                <a:spcPts val="0"/>
+              </a:spcBef>
+              <a:spcAft>
+                <a:spcPts val="0"/>
+              </a:spcAft>
+              <a:buNone/>
+            </a:pPr>
+            <a:r>
+              <a:rPr lang="en-GB" sz="730" dirty="0">
+                <a:solidFill>
+                  <a:srgbClr val="262626"/>
+                </a:solidFill>
+                <a:latin typeface="Arial"/>
+                <a:cs typeface="Arial"/>
+              </a:rPr>
               <a:t>El Heraldo 15 Feb 2026 (read); GAIN 2026</a:t>
             </a:r>
           </a:p>
@@ -10655,13 +10900,13 @@
       </p:sp>
       <p:sp>
         <p:nvSpPr>
-          <p:cNvPr id="79" name="TextBox 79"/>
-          <p:cNvSpPr txBox="1"/>
-          <p:nvPr/>
-        </p:nvSpPr>
-        <p:spPr>
-          <a:xfrm>
-            <a:off x="411480" y="5596128"/>
+          <p:cNvPr id="84" name="TextBox 84"/>
+          <p:cNvSpPr txBox="1"/>
+          <p:nvPr/>
+        </p:nvSpPr>
+        <p:spPr>
+          <a:xfrm>
+            <a:off x="411480" y="5893308"/>
             <a:ext cx="8961120" cy="502920"/>
           </a:xfrm>
           <a:prstGeom prst="rect">
@@ -10695,14 +10940,14 @@
                 <a:latin typeface="Arial"/>
                 <a:cs typeface="Arial"/>
               </a:rPr>
-              <a:t>IHCAFE rule: rust damage of 15 % ≈ 20 % less production (USDA 2017). Thresholds: 0–5 % low, 5–20 % medium. The monthly IHCAFE early-warning bulletins (about 1 200 farms) sit on ihcafe.hn, blocked here.</a:t>
-            </a:r>
-          </a:p>
-        </p:txBody>
-      </p:sp>
-      <p:sp>
-        <p:nvSpPr>
-          <p:cNvPr id="80" name="TextBox 80"/>
+              <a:t>IHCAFE rule: rust damage of 15 % ≈ 20 % less production (USDA 2017). Thresholds: 0–5 % low, 5–20 % medium. The monthly IHCAFE early-warning bulletins (about 1 200 farms) are no longer on ihcafe.hn: old links return the home page.</a:t>
+            </a:r>
+          </a:p>
+        </p:txBody>
+      </p:sp>
+      <p:sp>
+        <p:nvSpPr>
+          <p:cNvPr id="85" name="TextBox 85"/>
           <p:cNvSpPr txBox="1"/>
           <p:nvPr/>
         </p:nvSpPr>
@@ -10961,7 +11206,7 @@
       </p:sp>
       <p:sp>
         <p:nvSpPr>
-          <p:cNvPr id="81" name="TextBox 81"/>
+          <p:cNvPr id="86" name="TextBox 86"/>
           <p:cNvSpPr txBox="1"/>
           <p:nvPr/>
         </p:nvSpPr>

</xml_diff>